<commit_message>
RDH-3092 改判 uncertain（用戶定案）：現行 prompt 對照重標 100%/0%（n=137）
用戶複核＋原圖放大複驗證實借車照同區已可見鈑面變形，非原重標
「可見部分平整」——relabels.json 改判並完整註記（證據圖已入 repo）。

全數活文件對齊新口徑：README 成果摘要／評測規範／ablation 表、
簡報三檔（pptx 已重建）、隊友開工須知、training 對照、compare_prompts。
歷史 A/B 表保留原口徑加「歷史口徑」註——各變體落敗結論不變。
v6「抓回唯一漏檢」頭條在 README 正式撤回：A2 訊號抓到的是視角
可見度差而非新損，v6 僅剩結構性送審機制價值。
relabeled_metrics.json 更新並保留歷史值。

Co-Authored-By: Claude Fable 5 <noreply@anthropic.com>
</commit_message>
<xml_diff>
--- a/環節二_還車影像AI辨識/Timmy_Project_Report/presentation.pptx
+++ b/環節二_還車影像AI辨識/Timmy_Project_Report/presentation.pptx
@@ -1215,7 +1215,7 @@
           <a:lstStyle/>
           <a:p>
             <a:r>
-              <a:t>最重要一頁，講慢。21 組索賠 + 120 組未索賠。EXIF 轉正 +10pp；級聯升級 3% 案件到 Pro 三票多數決 +4.7pp（判定穩定性 99.3%）。之後 141 組逐圖重標：帳面的差距全是標籤錯誤（4 筆未索賠真損）或照片品質（5 組拍錯側/過暗排除）——138 組可判定樣本召回 95.5%、0 誤報，唯一漏抓是借車照被視角半遮的舊損密集車。分流 KPI（autopass_kpi.json）：83% 自動放行、15.6% 自動預警（高信心新損直接進車損流程）、1.4% 需人工複核；自動放行 117 件僅漏 1 件。注意：實測樣本刻意灌了 15% 索賠件，真實營運中車損比例遠低於此，自動放行率只會更高。</a:t>
+              <a:t>最重要一頁，講慢。21 組索賠 + 120 組未索賠。EXIF 轉正 +10pp；級聯升級 3% 案件到 Pro 三票多數決 +4.7pp（判定穩定性 99.3%）。之後 141 組逐圖重標：帳面的差距全是標籤錯誤（4 筆未索賠真損）或照片品質（6 組拍錯側/過暗/新舊難辨排除，含經原圖複驗改判存疑的 RDH-3092）——137 組可判定樣本召回 100%、0 誤報。分流 KPI（autopass_kpi.json）：83% 自動放行、15.6% 自動預警（高信心新損直接進車損流程）、1.4% 需人工複核；自動放行 117 件僅漏 1 件。注意：實測樣本刻意灌了 15% 索賠件，真實營運中車損比例遠低於此，自動放行率只會更高。</a:t>
             </a:r>
           </a:p>
         </p:txBody>
@@ -5115,7 +5115,7 @@
                 </a:solidFill>
                 <a:latin typeface="Helvetica Neue"/>
               </a:rPr>
-              <a:t>•  重標後 95.5% 召回・0 誤報・$0 原型</a:t>
+              <a:t>•  重標後 100% 召回・0 誤報・$0 原型</a:t>
             </a:r>
           </a:p>
           <a:p>
@@ -5764,7 +5764,7 @@
                 </a:solidFill>
                 <a:latin typeface="Helvetica Neue"/>
               </a:rPr>
-              <a:t>•  全量重標後：召回 95.5%、誤報 0%</a:t>
+              <a:t>•  全量重標後：召回 100%、誤報 0%（137 組可判定）</a:t>
             </a:r>
           </a:p>
           <a:p>

</xml_diff>

<commit_message>
Demo 一致性總修復：P0-P2 remediation 系列（Issues 1-8A）
依全專案 audit 逐項修復並驗證：
- 依賴：requirements 補 scipy（continuous_diff 硬依賴）與 python-pptx（簡報建置）
- 監理台：decide/undoDecision 修 fake success（HTTP 非 2xx 與斷網皆 rollback+alert）
- Live 車內判定：LiveInterior 加 photo_ok/invalid_reason，Flash 判無效必經 Pro
  確認、仍無效則 P2 重拍；photo_ok=false 優先於分級映射（+9 項契約測試，共 262）
- Demo 口徑統一：P1/P2 計數 22/2、P2 案例改 RDU-9162、FP 定案 2 真損/1 不可比
  /1 誤報（0.85%）、車內 80 候選→photo_ok 24/56→級聯分類 20/1/3
- 成本宣稱全面降級為「尚未完成正式驗證，不作量化宣稱」（Route A）
- 講稿補 6b/8b 兩頁；pptx 與單檔監理台重建；兩個線上 artifact 同 URL 更新
- 文件/註解清理：測試數 262、photo-chain 16 台、護照掛單 10 台、舊模型名中性化、
  quality_gate 車內門檻註解改為誠實的推論性描述（photo_ok 非人工 ground truth）

Co-Authored-By: Claude Fable 5 <noreply@anthropic.com>
</commit_message>
<xml_diff>
--- a/環節二_還車影像AI辨識/Timmy_Project_Report/presentation.pptx
+++ b/環節二_還車影像AI辨識/Timmy_Project_Report/presentation.pptx
@@ -585,7 +585,7 @@
           <a:lstStyle/>
           <a:p>
             <a:r>
-              <a:t>Demo：Dashboard 點「車輛損傷護照」→ RCR-7661。俯視圖上灰點=既有損（責任在前期）、紅點=本單新增（責任訂單明確），一張圖講完新舊分離與責任歸戶。實驗數據：護照登錄舊掉漆後仍 3/3 票抓到新增大損（conf 0.98）；原本判定會翻轉的 RDH-3092 變 3/3 一致。36 台車已建檔、9 台掛真實訂單。</a:t>
+              <a:t>Demo：Dashboard 點「車輛損傷護照」→ RCR-7661。俯視圖上灰點=既有損（責任在前期）、紅點=本單新增（責任訂單明確），一張圖講完新舊分離與責任歸戶。實驗數據：護照登錄舊掉漆後仍 3/3 票抓到新增大損（conf 0.98）；原本判定會翻轉的 RDH-3092 變 3/3 一致。36 台車已建檔、10 台掛真實訂單。</a:t>
             </a:r>
           </a:p>
         </p:txBody>
@@ -795,7 +795,7 @@
           <a:lstStyle/>
           <a:p>
             <a:r>
-              <a:t>以實測 token 用量換算（141 組共 349k 輸入/49k 輸出）。比一件爭議的人工處理成本還低。</a:t>
+              <a:t>成本驗證（實際計價模型與帳單核對）列為後續工作；今天不把 API 成本當量化成果。效益面：自動判讀取代人工逐單翻圖，並抓回人工漏登的車損（已確認 2 筆）。</a:t>
             </a:r>
           </a:p>
         </p:txBody>
@@ -1215,7 +1215,7 @@
           <a:lstStyle/>
           <a:p>
             <a:r>
-              <a:t>最重要一頁，講慢。21 組索賠 + 120 組未索賠。EXIF 轉正 +10pp；級聯升級 3% 案件到 Pro 三票多數決 +4.7pp（判定穩定性 99.3%）。之後 141 組逐圖重標：帳面的差距全是標籤錯誤（4 筆未索賠真損）或照片品質（6 組拍錯側/過暗/新舊難辨排除，含經原圖複驗改判存疑的 RDH-3092）——137 組可判定樣本召回 100%、0 誤報。分流 KPI（autopass_kpi.json）：83% 自動放行、15.6% 自動預警（高信心新損直接進車損流程）、1.4% 需人工複核；自動放行 117 件僅漏 1 件。注意：實測樣本刻意灌了 15% 索賠件，真實營運中車損比例遠低於此，自動放行率只會更高。</a:t>
+              <a:t>最重要一頁，講慢。21 組索賠 + 120 組未索賠。EXIF 轉正 +10pp；級聯把 3% 臨界案件改用 Pro 模型複核 +4.7pp（判定穩定性 99.3%）。★ 若被追問：這 +4.7pp 全部來自「換模型」——Flash 判無法比對而放棄的 RDY-6382，Pro 抓到藏在還2 補拍照的車門大凹陷。附帶的 3 票一致性檢查在 4 件升級案上全是 3:0、零分歧，未產生可測量效益，不可宣稱多數決提升準確率。之後 141 組逐圖重標，並於 2026-08-30 由用戶逐圖複核爭議樣本定案：帳面 4 筆「誤報」中 2 筆確為未索賠真損、1 筆是 AI 真誤報（RCG2235 右後，既有痕誤判新損）、1 筆借車照覆蓋不足不可比——137 組可判定樣本召回 100%（19/19）、誤報 0.85%（1/118）。分流 KPI（autopass_kpi.json）：83% 自動放行、15.6% 自動預警（高信心新損直接進車損流程）、1.4% 需人工複核；自動放行 117 件僅漏 1 件。注意：實測樣本刻意灌了 15% 索賠件，真實營運中車損比例遠低於此，自動放行率只會更高。</a:t>
             </a:r>
           </a:p>
         </p:txBody>
@@ -1285,7 +1285,7 @@
           <a:lstStyle/>
           <a:p>
             <a:r>
-              <a:t>F2 實測：40 筆訂單前後車內各一張，從 Azure Blob 下載真實照片。最大發現是資料品質：讓模型盤點問題並回報 photo_ok 後，56/80（70%）被誠實判定為「非車內照」——逐張人工抽驗證實真的是車外照誤置。這也解釋了為什麼欄位官方註記「上傳分類常有誤」，佐證環節一拍攝防呆的必要性。計分制（cleanliness_score.py）：AI 只盤點問題（11 類×3 級，附位置描述），扣分權重在程式端公開可調——與級聯判定一致率 91.7%，唯二不一致是「輕微遺留物該多重罰」的裁量案例（寶特瓶、衛生紙），正好示範權重可依營運政策調整。級聯亮點保留：Flash 判乾淨(0.65)的一張被 Pro 翻轉成髒汙（方向盤後方遺留寶特瓶）。</a:t>
+              <a:t>F2 實測：40 筆訂單前後車內各一張，從 Azure Blob 下載真實照片。最大發現是資料品質：讓模型盤點問題並回報 photo_ok 後，56/80（70%）被判定為不適合車內整潔判讀而排除（photo_ok 為模型判斷，非人工 ground truth）；人工抽驗 3 張未通過案例，3 張皆為車外照。這也解釋了為什麼欄位官方註記「上傳分類常有誤」，佐證環節一拍攝防呆的必要性。計分制（cleanliness_score.py）：AI 只盤點問題（11 類×3 級，附位置描述），扣分權重在程式端公開可調——與級聯判定一致率 91.7%，唯二不一致是「輕微遺留物該多重罰」的裁量案例（寶特瓶、衛生紙），正好示範權重可依營運政策調整。級聯亮點保留：Flash 判乾淨(0.65)的一張被 Pro 翻轉成髒汙（方向盤後方遺留寶特瓶）。</a:t>
             </a:r>
           </a:p>
         </p:txBody>
@@ -1355,7 +1355,7 @@
           <a:lstStyle/>
           <a:p>
             <a:r>
-              <a:t>故事高潮。建議貼 RFB5176 借/還對照圖。停頓後講：「它能挽回本來就該追回的損失。」</a:t>
+              <a:t>故事高潮。建議貼 RFB5176 借/還對照圖（2 筆確認漏登之一）。停頓後講：「AI 找到了原始標註漏掉的車損。」</a:t>
             </a:r>
           </a:p>
         </p:txBody>
@@ -4966,7 +4966,7 @@
                 </a:solidFill>
                 <a:latin typeface="Helvetica Neue"/>
               </a:rPr>
-              <a:t>•  每單判定成本 &lt; NT$1</a:t>
+              <a:t>•  成本尚未完成正式驗證</a:t>
             </a:r>
           </a:p>
           <a:p>
@@ -4982,7 +4982,7 @@
                 </a:solidFill>
                 <a:latin typeface="Helvetica Neue"/>
               </a:rPr>
-              <a:t>•  全量上線約 NT$1,200／日</a:t>
+              <a:t>•  本次不作量化成本宣稱</a:t>
             </a:r>
           </a:p>
           <a:p>
@@ -5115,7 +5115,7 @@
                 </a:solidFill>
                 <a:latin typeface="Helvetica Neue"/>
               </a:rPr>
-              <a:t>•  重標後 100% 召回・0 誤報・$0 原型</a:t>
+              <a:t>•  重標後 100% 召回・1 筆誤報</a:t>
             </a:r>
           </a:p>
           <a:p>
@@ -5764,7 +5764,7 @@
                 </a:solidFill>
                 <a:latin typeface="Helvetica Neue"/>
               </a:rPr>
-              <a:t>•  全量重標後：召回 100%、誤報 0%（137 組可判定）</a:t>
+              <a:t>•  全量重標後：召回 100%、誤報 0.85%（1 筆，137 組可判定）</a:t>
             </a:r>
           </a:p>
           <a:p>
@@ -5781,22 +5781,6 @@
                 <a:latin typeface="Helvetica Neue"/>
               </a:rPr>
               <a:t>•  自動放行 83%・需人工複核僅 1.4%</a:t>
-            </a:r>
-          </a:p>
-          <a:p>
-            <a:pPr algn="l">
-              <a:spcAft>
-                <a:spcPts val="1400"/>
-              </a:spcAft>
-            </a:pPr>
-            <a:r>
-              <a:rPr sz="2400">
-                <a:solidFill>
-                  <a:srgbClr val="1A1A1A"/>
-                </a:solidFill>
-                <a:latin typeface="Helvetica Neue"/>
-              </a:rPr>
-              <a:t>•  API 成本 $0（免費額度完成）</a:t>
             </a:r>
           </a:p>
         </p:txBody>
@@ -5842,7 +5826,7 @@
                 </a:solidFill>
                 <a:latin typeface="Helvetica Neue"/>
               </a:rPr>
-              <a:t>車內整潔實測｜80 張真實車內照</a:t>
+              <a:t>車內整潔實測｜80 張候選 → 24 張通過有效性檢查</a:t>
             </a:r>
           </a:p>
         </p:txBody>
@@ -5881,7 +5865,7 @@
                 </a:solidFill>
                 <a:latin typeface="Helvetica Neue"/>
               </a:rPr>
-              <a:t>•  驚人發現：70% 車內照欄位其實是車外照</a:t>
+              <a:t>•  80 張候選中 56 張（70%）未通過 photo_ok 檢查</a:t>
             </a:r>
           </a:p>
           <a:p>
@@ -5897,7 +5881,7 @@
                 </a:solidFill>
                 <a:latin typeface="Helvetica Neue"/>
               </a:rPr>
-              <a:t>•  真車內照 24 張：乾淨 20・普通 1・髒汙 3</a:t>
+              <a:t>•  級聯模型對通過檢查的 24 張分類：乾淨 20・普通 1・髒汙 3</a:t>
             </a:r>
           </a:p>
           <a:p>
@@ -6014,7 +5998,7 @@
                 </a:solidFill>
                 <a:latin typeface="Helvetica Neue"/>
               </a:rPr>
-              <a:t>•  「未索賠」樣本中抓出 4 筆真實新損</a:t>
+              <a:t>•  4 筆帳面誤報逐圖人工定案</a:t>
             </a:r>
           </a:p>
           <a:p>
@@ -6030,7 +6014,7 @@
                 </a:solidFill>
                 <a:latin typeface="Helvetica Neue"/>
               </a:rPr>
-              <a:t>•  借車照乾淨 → 還車照藍色擦痕</a:t>
+              <a:t>•  2 筆確認為人工漏登的真車損</a:t>
             </a:r>
           </a:p>
           <a:p>
@@ -6046,7 +6030,7 @@
                 </a:solidFill>
                 <a:latin typeface="Helvetica Neue"/>
               </a:rPr>
-              <a:t>•  逐圖放大複驗全數確認</a:t>
+              <a:t>•  另 1 筆不可比、1 筆為真正誤報</a:t>
             </a:r>
           </a:p>
           <a:p>
@@ -6062,7 +6046,7 @@
                 </a:solidFill>
                 <a:latin typeface="Helvetica Neue"/>
               </a:rPr>
-              <a:t>•  不只省人力，還挽回漏損</a:t>
+              <a:t>•  借車照乾淨 → 還車照藍色擦痕</a:t>
             </a:r>
           </a:p>
         </p:txBody>

</xml_diff>